<commit_message>
Prepare hackathon defense and simplify final repository
Keep source materials, the selected design, reproducible checks and five submission artifacts. Remove archived searches, intermediate candidates, draft slides and action journals. Correct engineering explanations and jury answers, fill the confirmed personal profile, and add a study guide. Preserve all eleven original source files and the selected RF results.
</commit_message>
<xml_diff>
--- a/presentation/defense.pptx
+++ b/presentation/defense.pptx
@@ -507,7 +507,23 @@
           <a:lstStyle/>
           <a:p>
             <a:r>
-              <a:t>Меня зовут Павел Абалаков. Учусь в УрТИСИ по направлению «Инфокоммуникационные технологии и системы связи». В профиле указаны второе место на хакатоне связи 2025 года и проект Payment OCR. Моя текущая роль: [УКАЗАТЬ РОЛЬ]. Личный вклад в проект: [УКАЗАТЬ ВКЛАД]. Профессиональные интересы: [УКАЗАТЬ ИНТЕРЕСЫ].</a:t>
+              <a:t>Меня зовут Павел Абалаков. Я студент третьего курса УрТИСИ, изучаю инфокоммуникационные технологии и системы связи. В командах Payment OCR и Magistral Dispatcher MAX выступал как product manager: распределял задачи и выстраивал коммуникацию. В Payment OCR также отвечал за архитектуру. Развиваюсь в product management и управлении проектами.</a:t>
+            </a:r>
+          </a:p>
+          <a:p/>
+          <a:p>
+            <a:r>
+              <a:t>Проекты:</a:t>
+            </a:r>
+          </a:p>
+          <a:p>
+            <a:r>
+              <a:t>Svyaz Hack Payment OCR: https://github.com/abalakovpa/svyaz-hack-payment-ocr</a:t>
+            </a:r>
+          </a:p>
+          <a:p>
+            <a:r>
+              <a:t>Magistral Dispatcher MAX: https://github.com/EEGRINO/magistral-dispatcher-max</a:t>
             </a:r>
           </a:p>
         </p:txBody>
@@ -647,7 +663,7 @@
           <a:lstStyle/>
           <a:p>
             <a:r>
-              <a:t>План построен по предоставленному DWG в исходном масштабе. После сравнения вариантов выбраны 32 двухпортовые In06 и четыре распределительные группы. Это один LTE-пул на каждом диапазоне, а не четыре независимые ячейки. Две MIMO-ветви проходят отдельно до двух портов каждой антенны. На каждой ветви гибриды объединяют операторов, триплексеры — диапазоны. В зоне две антенны подключены напрямую к PC252, две через PC250 и четыре через второй PC252. Доли мощности — четверть, восьмая и шестнадцатая. Это перераспределение при сохранении суммарной мощности. Существующая ВК не найдена: размещение головного узла в части 104.2 является моим проектным допущением. Помещение 89 не локализовано. Его площадь полностью учитывается как непокрытая. Исправлена геометрия четырёх спорных групп; неопределённость 114.2 сохранена.</a:t>
+              <a:t>План построен по предоставленному DWG в исходном масштабе. Выбраны 32 двухпортовые In06 и четыре распределительные группы; их покрытие проверено расчётом. Это один LTE-пул на каждом диапазоне, а не четыре независимые ячейки. Две MIMO-ветви проходят отдельно до двух портов каждой антенны. На каждой ветви гибриды объединяют операторов, триплексеры — диапазоны. В зоне две антенны подключены напрямую к PC252, две через PC250 и четыре через второй PC252. Доли мощности — четверть, восьмая и шестнадцатая. Это перераспределение при сохранении суммарной мощности. Существующая ВК не найдена: размещение головного узла в части 104.2 является моим проектным допущением. Помещение 89 не локализовано. Его площадь полностью учитывается как непокрытая. Исправлена геометрия четырёх спорных групп; неопределённость 114.2 сохранена.</a:t>
             </a:r>
           </a:p>
         </p:txBody>
@@ -717,7 +733,7 @@
           <a:lstStyle/>
           <a:p>
             <a:r>
-              <a:t>Рассчитаны 384 сочетания антенны, диапазона и расстояния, а также карта с шагом 25 сантиметров. В модели учитываются кабели, делители, высота и пересечения стен. Пилот 23 дБм условно нормирован на CRS одного порта; определение мощности в задании неоднозначно. На B7 номинальный результат составляет 96.58 процента от заданных 2100 квадратных метров. При показателе затухания n=3 — 96.37 процента. При дополнительных трёх децибелах остаётся 96.51 процента. При закрытых проёмах, исключении спорного контура и ещё трёх децибелах — 96.32 процента. Запас достигнут в модели. Худший отдельный путь на 20 метрах даёт -95.64 дБм; площадь оценивается по всем антеннам. Это сценарный прогноз, а не измерения. RSRP не подтверждает SINR, RSRQ или скорость. Для DCS отдельно проверены условные мощности BCCH, но не внешний C/I.</a:t>
+              <a:t>Рассчитаны 384 сочетания антенны, диапазона и расстояния, а также карта с шагом 25 сантиметров. В модели учитываются кабели, делители, высота и пересечения стен. Пилот 23 дБм условно нормирован на CRS одного порта; определение мощности в задании неоднозначно. На B7 номинальный результат составляет 96.58 процента от заданных 2100 квадратных метров. При показателе затухания n=3 — 96.37 процента. В отдельной проверке дополнительных трёх децибел остаётся 96.51 процента. При закрытых проёмах, исключении спорного контура и ещё трёх децибелах — 96.32 процента. Запас достигнут в модели. Худший отдельный путь на 20 метрах даёт -95.64 дБм; площадь оценивается по всем антеннам. Это сценарный прогноз, а не измерения. RSRP не подтверждает SINR, RSRQ или скорость. Для DCS отдельно проверены условные мощности BCCH, но не внешний C/I.</a:t>
             </a:r>
           </a:p>
         </p:txBody>
@@ -787,7 +803,7 @@
           <a:lstStyle/>
           <a:p>
             <a:r>
-              <a:t>Спецификация формируется из той же структуры, что схемы и трассы. В ней только позиции предоставленного перечня. Учтены 32 антенны, шесть гибридов, восемь триплексеров, девять двухвыходных и шестнадцать четырёхвыходных делителей. Кабель с резервом: 1366 метров семь восьмых и 179 метров одна вторая. По сравнению с предыдущим вариантом метраж коаксиала сокращён примерно на 4 процента. Всего 113 джамперов, включая 12 резервных входных и 4 местных. Для свободных портов нужны нагрузки, отсутствующие в перечне; пожарная модификация и исполнения разъёмов также не подтверждены.</a:t>
+              <a:t>Спецификация формируется из той же структуры, что схемы и трассы. В ней только позиции предоставленного перечня. Учтены 32 антенны, шесть гибридов, восемь триплексеров, девять двухвыходных и шестнадцать четырёхвыходных делителей. Кабель с резервом: 1366 метров семь восьмых и 179 метров одна вторая. Установленный метраж коаксиала двух ветвей составляет 1404 метра. Всего 113 джамперов, включая 12 резервных входных и 4 местных. Для свободных портов нужны нагрузки, отсутствующие в перечне; пожарная модификация и исполнения разъёмов также не подтверждены.</a:t>
             </a:r>
           </a:p>
         </p:txBody>
@@ -857,7 +873,7 @@
           <a:lstStyle/>
           <a:p>
             <a:r>
-              <a:t>Три главных решения — общий пул с новой моделью спроса, восстановление контуров и неравномерное распределение мощности. Две MIMO-ветви сохранены. Числа согласованы и воспроизводимы. Номинальная модель, n=3 и запас три децибела проходят; другое определение пилота P2 не проходит. Полное соответствие заданию не доказано: помеховые показатели неизвестны, пассивная схема не обеспечивает требуемое удалённое регулирование, часть комплектации не подтверждена. Эти ограничения отражены в документах, а не скрыты за проходящим номинальным результатом.</a:t>
+              <a:t>Три главных решения — общий пул с новой моделью спроса, восстановление контуров и неравномерное распределение мощности. Две MIMO-ветви сохранены. Числа согласованы и воспроизводимы. Номинальная модель и отдельные проверки n=3 и запаса три децибела проходят; другое определение пилота P2 не проходит. Полное соответствие заданию не доказано: помеховые показатели неизвестны, пассивная схема не обеспечивает требуемое удалённое регулирование, часть комплектации не подтверждена. Эти ограничения отражены в документах, а не скрыты за проходящим номинальным результатом.</a:t>
             </a:r>
           </a:p>
         </p:txBody>
@@ -4124,7 +4140,7 @@
               </a:defRPr>
             </a:pPr>
             <a:r>
-              <a:t>УрТИСИ · 11.03.02 · Инфокоммуникационные технологии и</a:t>
+              <a:t>УрТИСИ · III курс · 11.03.02 · Инфокоммуникационные</a:t>
             </a:r>
           </a:p>
           <a:p>
@@ -4146,7 +4162,7 @@
               </a:defRPr>
             </a:pPr>
             <a:r>
-              <a:t>системы связи</a:t>
+              <a:t>технологии и системы связи</a:t>
             </a:r>
           </a:p>
         </p:txBody>
@@ -4191,7 +4207,7 @@
               </a:defRPr>
             </a:pPr>
             <a:r>
-              <a:t>III курс по профилю GitHub; II место — хакатон связи, 2025</a:t>
+              <a:t>II место — хакатон связи, 2025</a:t>
             </a:r>
           </a:p>
         </p:txBody>
@@ -4204,7 +4220,7 @@
         </p:nvSpPr>
         <p:spPr>
           <a:xfrm>
-            <a:off x="594360" y="3474720"/>
+            <a:off x="594360" y="3383280"/>
             <a:ext cx="10789920" cy="640080"/>
           </a:xfrm>
           <a:prstGeom prst="rect">
@@ -4220,7 +4236,7 @@
           <a:p>
             <a:pPr>
               <a:lnSpc>
-                <a:spcPts val="2760"/>
+                <a:spcPts val="2645"/>
               </a:lnSpc>
               <a:spcBef>
                 <a:spcPts val="0"/>
@@ -4228,7 +4244,7 @@
               <a:spcAft>
                 <a:spcPts val="0"/>
               </a:spcAft>
-              <a:defRPr sz="2400" b="0">
+              <a:defRPr sz="2300" b="0">
                 <a:solidFill>
                   <a:srgbClr val="17324D"/>
                 </a:solidFill>
@@ -4236,7 +4252,7 @@
               </a:defRPr>
             </a:pPr>
             <a:r>
-              <a:t>Проект: Svyaz Hack Payment OCR</a:t>
+              <a:t>Проекты: Payment OCR · Magistral Dispatcher MAX</a:t>
             </a:r>
           </a:p>
         </p:txBody>
@@ -4249,14 +4265,14 @@
         </p:nvSpPr>
         <p:spPr>
           <a:xfrm>
-            <a:off x="548640" y="4389120"/>
-            <a:ext cx="11064240" cy="1645920"/>
+            <a:off x="548640" y="4206240"/>
+            <a:ext cx="11064240" cy="1920240"/>
           </a:xfrm>
           <a:prstGeom prst="rect">
             <a:avLst/>
           </a:prstGeom>
           <a:solidFill>
-            <a:srgbClr val="FFF0D8"/>
+            <a:srgbClr val="EAF2F8"/>
           </a:solidFill>
           <a:ln>
             <a:noFill/>
@@ -4292,8 +4308,8 @@
         </p:nvSpPr>
         <p:spPr>
           <a:xfrm>
-            <a:off x="777240" y="4572000"/>
-            <a:ext cx="10515600" cy="1280160"/>
+            <a:off x="777240" y="4389120"/>
+            <a:ext cx="10515600" cy="1554480"/>
           </a:xfrm>
           <a:prstGeom prst="rect">
             <a:avLst/>
@@ -4308,7 +4324,7 @@
           <a:p>
             <a:pPr>
               <a:lnSpc>
-                <a:spcPts val="2185"/>
+                <a:spcPts val="2070"/>
               </a:lnSpc>
               <a:spcBef>
                 <a:spcPts val="0"/>
@@ -4316,7 +4332,7 @@
               <a:spcAft>
                 <a:spcPts val="0"/>
               </a:spcAft>
-              <a:defRPr sz="1900" b="0">
+              <a:defRPr sz="1800" b="0">
                 <a:solidFill>
                   <a:srgbClr val="17324D"/>
                 </a:solidFill>
@@ -4324,13 +4340,13 @@
               </a:defRPr>
             </a:pPr>
             <a:r>
-              <a:t>Роль: [заполнить]</a:t>
+              <a:t>Роль: Студент; product manager в проектных командах</a:t>
             </a:r>
           </a:p>
           <a:p>
             <a:pPr>
               <a:lnSpc>
-                <a:spcPts val="2185"/>
+                <a:spcPts val="2070"/>
               </a:lnSpc>
               <a:spcBef>
                 <a:spcPts val="0"/>
@@ -4338,7 +4354,7 @@
               <a:spcAft>
                 <a:spcPts val="0"/>
               </a:spcAft>
-              <a:defRPr sz="1900" b="0">
+              <a:defRPr sz="1800" b="0">
                 <a:solidFill>
                   <a:srgbClr val="17324D"/>
                 </a:solidFill>
@@ -4346,13 +4362,13 @@
               </a:defRPr>
             </a:pPr>
             <a:r>
-              <a:t>Вклад: [заполнить]</a:t>
+              <a:t>Вклад: Payment OCR: архитектура; оба проекта: задачи и командная коммуникация</a:t>
             </a:r>
           </a:p>
           <a:p>
             <a:pPr>
               <a:lnSpc>
-                <a:spcPts val="2185"/>
+                <a:spcPts val="2070"/>
               </a:lnSpc>
               <a:spcBef>
                 <a:spcPts val="0"/>
@@ -4360,7 +4376,7 @@
               <a:spcAft>
                 <a:spcPts val="0"/>
               </a:spcAft>
-              <a:defRPr sz="1900" b="0">
+              <a:defRPr sz="1800" b="0">
                 <a:solidFill>
                   <a:srgbClr val="17324D"/>
                 </a:solidFill>
@@ -4368,7 +4384,7 @@
               </a:defRPr>
             </a:pPr>
             <a:r>
-              <a:t>Интересы: [заполнить]</a:t>
+              <a:t>Интересы: Product management, управление проектами и командная коммуникация</a:t>
             </a:r>
           </a:p>
         </p:txBody>
@@ -5449,7 +5465,7 @@
               </a:defRPr>
             </a:pPr>
             <a:r>
-              <a:t>Коаксиал: 1404 м; -3.9% к предыдущей схеме.</a:t>
+              <a:t>Коаксиал двух ветвей: 1404 м.</a:t>
             </a:r>
           </a:p>
         </p:txBody>
@@ -6837,7 +6853,7 @@
               </a:defRPr>
             </a:pPr>
             <a:r>
-              <a:t>P1, n=3 и запас 3 дБ проходят; нормировка P2 — нет.</a:t>
+              <a:t>P1: n=3 и +3 дБ проходят в отдельных проверках.</a:t>
             </a:r>
           </a:p>
           <a:p>
@@ -6859,7 +6875,7 @@
               </a:defRPr>
             </a:pPr>
             <a:r>
-              <a:t>RSRQ / SINR / C/I / UL не подтверждены.</a:t>
+              <a:t>P2, RSRQ / SINR / C/I / UL остаются ограничениями.</a:t>
             </a:r>
           </a:p>
           <a:p>

</xml_diff>